<commit_message>
slides(blimp): enlarge answers and simplify paper references
</commit_message>
<xml_diff>
--- a/slides/datasets-in-10-minutes-blimp.pptx
+++ b/slides/datasets-in-10-minutes-blimp.pptx
@@ -10443,7 +10443,7 @@
                 <a:ea typeface="Noto Sans CJK JP"/>
                 <a:cs typeface="Noto Sans"/>
               </a:rPr>
-              <a:t>論文Table 3の強制二択。多数決ラベルの一致率96.4%とは別の量。</a:t>
+              <a:t>強制二択で評価。多数決ラベルの一致率96.4%とは別の量。</a:t>
             </a:r>
           </a:p>
         </p:txBody>
@@ -13322,8 +13322,8 @@
         </p:nvSpPr>
         <p:spPr>
           <a:xfrm>
-            <a:off x="6583680" y="1271016"/>
-            <a:ext cx="1965960" cy="201168"/>
+            <a:off x="5303520" y="1216152"/>
+            <a:ext cx="3246120" cy="384048"/>
           </a:xfrm>
           <a:prstGeom prst="rect">
             <a:avLst/>
@@ -13331,14 +13331,14 @@
           <a:noFill/>
         </p:spPr>
         <p:txBody>
-          <a:bodyPr wrap="square" lIns="0" rIns="0" tIns="0" bIns="0">
+          <a:bodyPr wrap="none" lIns="0" rIns="0" tIns="0" bIns="0">
             <a:noAutofit/>
           </a:bodyPr>
           <a:lstStyle/>
           <a:p>
-            <a:pPr algn="l">
-              <a:lnSpc>
-                <a:spcPct val="117000"/>
+            <a:pPr algn="r">
+              <a:lnSpc>
+                <a:spcPts val="2640"/>
               </a:lnSpc>
               <a:spcBef>
                 <a:spcPts val="0"/>
@@ -13355,7 +13355,7 @@
               </a:defRPr>
             </a:pPr>
             <a:r>
-              <a:rPr sz="1250" b="1" lang="ja-JP" altLang="en-US">
+              <a:rPr sz="2200" b="1" lang="ja-JP" altLang="en-US">
                 <a:solidFill>
                   <a:srgbClr val="2C9100"/>
                 </a:solidFill>
@@ -13811,8 +13811,8 @@
         </p:nvSpPr>
         <p:spPr>
           <a:xfrm>
-            <a:off x="6583680" y="1271016"/>
-            <a:ext cx="1965960" cy="201168"/>
+            <a:off x="5303520" y="1216152"/>
+            <a:ext cx="3246120" cy="384048"/>
           </a:xfrm>
           <a:prstGeom prst="rect">
             <a:avLst/>
@@ -13820,14 +13820,14 @@
           <a:noFill/>
         </p:spPr>
         <p:txBody>
-          <a:bodyPr wrap="square" lIns="0" rIns="0" tIns="0" bIns="0">
+          <a:bodyPr wrap="none" lIns="0" rIns="0" tIns="0" bIns="0">
             <a:noAutofit/>
           </a:bodyPr>
           <a:lstStyle/>
           <a:p>
-            <a:pPr algn="l">
-              <a:lnSpc>
-                <a:spcPct val="117000"/>
+            <a:pPr algn="r">
+              <a:lnSpc>
+                <a:spcPts val="2640"/>
               </a:lnSpc>
               <a:spcBef>
                 <a:spcPts val="0"/>
@@ -13844,7 +13844,7 @@
               </a:defRPr>
             </a:pPr>
             <a:r>
-              <a:rPr sz="1250" b="1" lang="ja-JP" altLang="en-US">
+              <a:rPr sz="2200" b="1" lang="ja-JP" altLang="en-US">
                 <a:solidFill>
                   <a:srgbClr val="2C9100"/>
                 </a:solidFill>
@@ -14300,8 +14300,8 @@
         </p:nvSpPr>
         <p:spPr>
           <a:xfrm>
-            <a:off x="6583680" y="1271016"/>
-            <a:ext cx="1965960" cy="201168"/>
+            <a:off x="5303520" y="1216152"/>
+            <a:ext cx="3246120" cy="384048"/>
           </a:xfrm>
           <a:prstGeom prst="rect">
             <a:avLst/>
@@ -14309,14 +14309,14 @@
           <a:noFill/>
         </p:spPr>
         <p:txBody>
-          <a:bodyPr wrap="square" lIns="0" rIns="0" tIns="0" bIns="0">
+          <a:bodyPr wrap="none" lIns="0" rIns="0" tIns="0" bIns="0">
             <a:noAutofit/>
           </a:bodyPr>
           <a:lstStyle/>
           <a:p>
-            <a:pPr algn="l">
-              <a:lnSpc>
-                <a:spcPct val="117000"/>
+            <a:pPr algn="r">
+              <a:lnSpc>
+                <a:spcPts val="2640"/>
               </a:lnSpc>
               <a:spcBef>
                 <a:spcPts val="0"/>
@@ -14333,7 +14333,7 @@
               </a:defRPr>
             </a:pPr>
             <a:r>
-              <a:rPr sz="1250" b="1" lang="ja-JP" altLang="en-US">
+              <a:rPr sz="2200" b="1" lang="ja-JP" altLang="en-US">
                 <a:solidFill>
                   <a:srgbClr val="2C9100"/>
                 </a:solidFill>
@@ -15046,8 +15046,8 @@
         </p:nvSpPr>
         <p:spPr>
           <a:xfrm>
-            <a:off x="6583680" y="1271016"/>
-            <a:ext cx="1965960" cy="201168"/>
+            <a:off x="5303520" y="1216152"/>
+            <a:ext cx="3246120" cy="384048"/>
           </a:xfrm>
           <a:prstGeom prst="rect">
             <a:avLst/>
@@ -15055,14 +15055,14 @@
           <a:noFill/>
         </p:spPr>
         <p:txBody>
-          <a:bodyPr wrap="square" lIns="0" rIns="0" tIns="0" bIns="0">
+          <a:bodyPr wrap="none" lIns="0" rIns="0" tIns="0" bIns="0">
             <a:noAutofit/>
           </a:bodyPr>
           <a:lstStyle/>
           <a:p>
-            <a:pPr algn="l">
-              <a:lnSpc>
-                <a:spcPct val="117000"/>
+            <a:pPr algn="r">
+              <a:lnSpc>
+                <a:spcPts val="2640"/>
               </a:lnSpc>
               <a:spcBef>
                 <a:spcPts val="0"/>
@@ -15079,7 +15079,7 @@
               </a:defRPr>
             </a:pPr>
             <a:r>
-              <a:rPr sz="1250" b="1" lang="ja-JP" altLang="en-US">
+              <a:rPr sz="2200" b="1" lang="ja-JP" altLang="en-US">
                 <a:solidFill>
                   <a:srgbClr val="2C9100"/>
                 </a:solidFill>
@@ -15535,8 +15535,8 @@
         </p:nvSpPr>
         <p:spPr>
           <a:xfrm>
-            <a:off x="6583680" y="1271016"/>
-            <a:ext cx="1965960" cy="201168"/>
+            <a:off x="5303520" y="1216152"/>
+            <a:ext cx="3246120" cy="384048"/>
           </a:xfrm>
           <a:prstGeom prst="rect">
             <a:avLst/>
@@ -15544,14 +15544,14 @@
           <a:noFill/>
         </p:spPr>
         <p:txBody>
-          <a:bodyPr wrap="square" lIns="0" rIns="0" tIns="0" bIns="0">
+          <a:bodyPr wrap="none" lIns="0" rIns="0" tIns="0" bIns="0">
             <a:noAutofit/>
           </a:bodyPr>
           <a:lstStyle/>
           <a:p>
-            <a:pPr algn="l">
-              <a:lnSpc>
-                <a:spcPct val="117000"/>
+            <a:pPr algn="r">
+              <a:lnSpc>
+                <a:spcPts val="2640"/>
               </a:lnSpc>
               <a:spcBef>
                 <a:spcPts val="0"/>
@@ -15568,7 +15568,7 @@
               </a:defRPr>
             </a:pPr>
             <a:r>
-              <a:rPr sz="1250" b="1" lang="ja-JP" altLang="en-US">
+              <a:rPr sz="2200" b="1" lang="ja-JP" altLang="en-US">
                 <a:solidFill>
                   <a:srgbClr val="2C9100"/>
                 </a:solidFill>
@@ -16024,8 +16024,8 @@
         </p:nvSpPr>
         <p:spPr>
           <a:xfrm>
-            <a:off x="6583680" y="1271016"/>
-            <a:ext cx="1965960" cy="201168"/>
+            <a:off x="5303520" y="1216152"/>
+            <a:ext cx="3246120" cy="384048"/>
           </a:xfrm>
           <a:prstGeom prst="rect">
             <a:avLst/>
@@ -16033,14 +16033,14 @@
           <a:noFill/>
         </p:spPr>
         <p:txBody>
-          <a:bodyPr wrap="square" lIns="0" rIns="0" tIns="0" bIns="0">
+          <a:bodyPr wrap="none" lIns="0" rIns="0" tIns="0" bIns="0">
             <a:noAutofit/>
           </a:bodyPr>
           <a:lstStyle/>
           <a:p>
-            <a:pPr algn="l">
-              <a:lnSpc>
-                <a:spcPct val="117000"/>
+            <a:pPr algn="r">
+              <a:lnSpc>
+                <a:spcPts val="2640"/>
               </a:lnSpc>
               <a:spcBef>
                 <a:spcPts val="0"/>
@@ -16057,7 +16057,7 @@
               </a:defRPr>
             </a:pPr>
             <a:r>
-              <a:rPr sz="1250" b="1" lang="ja-JP" altLang="en-US">
+              <a:rPr sz="2200" b="1" lang="ja-JP" altLang="en-US">
                 <a:solidFill>
                   <a:srgbClr val="2C9100"/>
                 </a:solidFill>
@@ -16513,8 +16513,8 @@
         </p:nvSpPr>
         <p:spPr>
           <a:xfrm>
-            <a:off x="6583680" y="1271016"/>
-            <a:ext cx="1965960" cy="201168"/>
+            <a:off x="5303520" y="1216152"/>
+            <a:ext cx="3246120" cy="384048"/>
           </a:xfrm>
           <a:prstGeom prst="rect">
             <a:avLst/>
@@ -16522,14 +16522,14 @@
           <a:noFill/>
         </p:spPr>
         <p:txBody>
-          <a:bodyPr wrap="square" lIns="0" rIns="0" tIns="0" bIns="0">
+          <a:bodyPr wrap="none" lIns="0" rIns="0" tIns="0" bIns="0">
             <a:noAutofit/>
           </a:bodyPr>
           <a:lstStyle/>
           <a:p>
-            <a:pPr algn="l">
-              <a:lnSpc>
-                <a:spcPct val="117000"/>
+            <a:pPr algn="r">
+              <a:lnSpc>
+                <a:spcPts val="2640"/>
               </a:lnSpc>
               <a:spcBef>
                 <a:spcPts val="0"/>
@@ -16546,7 +16546,7 @@
               </a:defRPr>
             </a:pPr>
             <a:r>
-              <a:rPr sz="1250" b="1" lang="ja-JP" altLang="en-US">
+              <a:rPr sz="2200" b="1" lang="ja-JP" altLang="en-US">
                 <a:solidFill>
                   <a:srgbClr val="2C9100"/>
                 </a:solidFill>
@@ -17002,8 +17002,8 @@
         </p:nvSpPr>
         <p:spPr>
           <a:xfrm>
-            <a:off x="6583680" y="1271016"/>
-            <a:ext cx="1965960" cy="201168"/>
+            <a:off x="5303520" y="1216152"/>
+            <a:ext cx="3246120" cy="384048"/>
           </a:xfrm>
           <a:prstGeom prst="rect">
             <a:avLst/>
@@ -17011,14 +17011,14 @@
           <a:noFill/>
         </p:spPr>
         <p:txBody>
-          <a:bodyPr wrap="square" lIns="0" rIns="0" tIns="0" bIns="0">
+          <a:bodyPr wrap="none" lIns="0" rIns="0" tIns="0" bIns="0">
             <a:noAutofit/>
           </a:bodyPr>
           <a:lstStyle/>
           <a:p>
-            <a:pPr algn="l">
-              <a:lnSpc>
-                <a:spcPct val="117000"/>
+            <a:pPr algn="r">
+              <a:lnSpc>
+                <a:spcPts val="2640"/>
               </a:lnSpc>
               <a:spcBef>
                 <a:spcPts val="0"/>
@@ -17035,7 +17035,7 @@
               </a:defRPr>
             </a:pPr>
             <a:r>
-              <a:rPr sz="1250" b="1" lang="ja-JP" altLang="en-US">
+              <a:rPr sz="2200" b="1" lang="ja-JP" altLang="en-US">
                 <a:solidFill>
                   <a:srgbClr val="2C9100"/>
                 </a:solidFill>
@@ -17491,8 +17491,8 @@
         </p:nvSpPr>
         <p:spPr>
           <a:xfrm>
-            <a:off x="6583680" y="1271016"/>
-            <a:ext cx="1965960" cy="201168"/>
+            <a:off x="5303520" y="1216152"/>
+            <a:ext cx="3246120" cy="384048"/>
           </a:xfrm>
           <a:prstGeom prst="rect">
             <a:avLst/>
@@ -17500,14 +17500,14 @@
           <a:noFill/>
         </p:spPr>
         <p:txBody>
-          <a:bodyPr wrap="square" lIns="0" rIns="0" tIns="0" bIns="0">
+          <a:bodyPr wrap="none" lIns="0" rIns="0" tIns="0" bIns="0">
             <a:noAutofit/>
           </a:bodyPr>
           <a:lstStyle/>
           <a:p>
-            <a:pPr algn="l">
-              <a:lnSpc>
-                <a:spcPct val="117000"/>
+            <a:pPr algn="r">
+              <a:lnSpc>
+                <a:spcPts val="2640"/>
               </a:lnSpc>
               <a:spcBef>
                 <a:spcPts val="0"/>
@@ -17524,7 +17524,7 @@
               </a:defRPr>
             </a:pPr>
             <a:r>
-              <a:rPr sz="1250" b="1" lang="ja-JP" altLang="en-US">
+              <a:rPr sz="2200" b="1" lang="ja-JP" altLang="en-US">
                 <a:solidFill>
                   <a:srgbClr val="2C9100"/>
                 </a:solidFill>
@@ -17980,8 +17980,8 @@
         </p:nvSpPr>
         <p:spPr>
           <a:xfrm>
-            <a:off x="6583680" y="1271016"/>
-            <a:ext cx="1965960" cy="201168"/>
+            <a:off x="5303520" y="1216152"/>
+            <a:ext cx="3246120" cy="384048"/>
           </a:xfrm>
           <a:prstGeom prst="rect">
             <a:avLst/>
@@ -17989,14 +17989,14 @@
           <a:noFill/>
         </p:spPr>
         <p:txBody>
-          <a:bodyPr wrap="square" lIns="0" rIns="0" tIns="0" bIns="0">
+          <a:bodyPr wrap="none" lIns="0" rIns="0" tIns="0" bIns="0">
             <a:noAutofit/>
           </a:bodyPr>
           <a:lstStyle/>
           <a:p>
-            <a:pPr algn="l">
-              <a:lnSpc>
-                <a:spcPct val="117000"/>
+            <a:pPr algn="r">
+              <a:lnSpc>
+                <a:spcPts val="2640"/>
               </a:lnSpc>
               <a:spcBef>
                 <a:spcPts val="0"/>
@@ -18013,7 +18013,7 @@
               </a:defRPr>
             </a:pPr>
             <a:r>
-              <a:rPr sz="1250" b="1" lang="ja-JP" altLang="en-US">
+              <a:rPr sz="2200" b="1" lang="ja-JP" altLang="en-US">
                 <a:solidFill>
                   <a:srgbClr val="2C9100"/>
                 </a:solidFill>
@@ -22698,8 +22698,8 @@
         </p:nvSpPr>
         <p:spPr>
           <a:xfrm>
-            <a:off x="6583680" y="1271016"/>
-            <a:ext cx="1965960" cy="201168"/>
+            <a:off x="5303520" y="1216152"/>
+            <a:ext cx="3246120" cy="384048"/>
           </a:xfrm>
           <a:prstGeom prst="rect">
             <a:avLst/>
@@ -22707,14 +22707,14 @@
           <a:noFill/>
         </p:spPr>
         <p:txBody>
-          <a:bodyPr wrap="square" lIns="0" rIns="0" tIns="0" bIns="0">
+          <a:bodyPr wrap="none" lIns="0" rIns="0" tIns="0" bIns="0">
             <a:noAutofit/>
           </a:bodyPr>
           <a:lstStyle/>
           <a:p>
-            <a:pPr algn="l">
-              <a:lnSpc>
-                <a:spcPct val="117000"/>
+            <a:pPr algn="r">
+              <a:lnSpc>
+                <a:spcPts val="2640"/>
               </a:lnSpc>
               <a:spcBef>
                 <a:spcPts val="0"/>
@@ -22731,7 +22731,7 @@
               </a:defRPr>
             </a:pPr>
             <a:r>
-              <a:rPr sz="1250" b="1" lang="ja-JP" altLang="en-US">
+              <a:rPr sz="2200" b="1" lang="ja-JP" altLang="en-US">
                 <a:solidFill>
                   <a:srgbClr val="2C9100"/>
                 </a:solidFill>
@@ -23187,8 +23187,8 @@
         </p:nvSpPr>
         <p:spPr>
           <a:xfrm>
-            <a:off x="6583680" y="1271016"/>
-            <a:ext cx="1965960" cy="201168"/>
+            <a:off x="5303520" y="1216152"/>
+            <a:ext cx="3246120" cy="384048"/>
           </a:xfrm>
           <a:prstGeom prst="rect">
             <a:avLst/>
@@ -23196,14 +23196,14 @@
           <a:noFill/>
         </p:spPr>
         <p:txBody>
-          <a:bodyPr wrap="square" lIns="0" rIns="0" tIns="0" bIns="0">
+          <a:bodyPr wrap="none" lIns="0" rIns="0" tIns="0" bIns="0">
             <a:noAutofit/>
           </a:bodyPr>
           <a:lstStyle/>
           <a:p>
-            <a:pPr algn="l">
-              <a:lnSpc>
-                <a:spcPct val="117000"/>
+            <a:pPr algn="r">
+              <a:lnSpc>
+                <a:spcPts val="2640"/>
               </a:lnSpc>
               <a:spcBef>
                 <a:spcPts val="0"/>
@@ -23220,7 +23220,7 @@
               </a:defRPr>
             </a:pPr>
             <a:r>
-              <a:rPr sz="1250" b="1" lang="ja-JP" altLang="en-US">
+              <a:rPr sz="2200" b="1" lang="ja-JP" altLang="en-US">
                 <a:solidFill>
                   <a:srgbClr val="2C9100"/>
                 </a:solidFill>
@@ -23676,8 +23676,8 @@
         </p:nvSpPr>
         <p:spPr>
           <a:xfrm>
-            <a:off x="6583680" y="1271016"/>
-            <a:ext cx="1965960" cy="201168"/>
+            <a:off x="5303520" y="1216152"/>
+            <a:ext cx="3246120" cy="384048"/>
           </a:xfrm>
           <a:prstGeom prst="rect">
             <a:avLst/>
@@ -23685,14 +23685,14 @@
           <a:noFill/>
         </p:spPr>
         <p:txBody>
-          <a:bodyPr wrap="square" lIns="0" rIns="0" tIns="0" bIns="0">
+          <a:bodyPr wrap="none" lIns="0" rIns="0" tIns="0" bIns="0">
             <a:noAutofit/>
           </a:bodyPr>
           <a:lstStyle/>
           <a:p>
-            <a:pPr algn="l">
-              <a:lnSpc>
-                <a:spcPct val="117000"/>
+            <a:pPr algn="r">
+              <a:lnSpc>
+                <a:spcPts val="2640"/>
               </a:lnSpc>
               <a:spcBef>
                 <a:spcPts val="0"/>
@@ -23709,7 +23709,7 @@
               </a:defRPr>
             </a:pPr>
             <a:r>
-              <a:rPr sz="1250" b="1" lang="ja-JP" altLang="en-US">
+              <a:rPr sz="2200" b="1" lang="ja-JP" altLang="en-US">
                 <a:solidFill>
                   <a:srgbClr val="2C9100"/>
                 </a:solidFill>

</xml_diff>

<commit_message>
slides(blimp): use burgundy theme accent for answers
</commit_message>
<xml_diff>
--- a/slides/datasets-in-10-minutes-blimp.pptx
+++ b/slides/datasets-in-10-minutes-blimp.pptx
@@ -13357,7 +13357,7 @@
             <a:r>
               <a:rPr sz="2200" b="1" lang="ja-JP" altLang="en-US">
                 <a:solidFill>
-                  <a:srgbClr val="2C9100"/>
+                  <a:schemeClr val="accent1"/>
                 </a:solidFill>
                 <a:latin typeface="Noto Sans"/>
                 <a:ea typeface="Noto Sans CJK JP"/>
@@ -13846,7 +13846,7 @@
             <a:r>
               <a:rPr sz="2200" b="1" lang="ja-JP" altLang="en-US">
                 <a:solidFill>
-                  <a:srgbClr val="2C9100"/>
+                  <a:schemeClr val="accent1"/>
                 </a:solidFill>
                 <a:latin typeface="Noto Sans"/>
                 <a:ea typeface="Noto Sans CJK JP"/>
@@ -14335,7 +14335,7 @@
             <a:r>
               <a:rPr sz="2200" b="1" lang="ja-JP" altLang="en-US">
                 <a:solidFill>
-                  <a:srgbClr val="2C9100"/>
+                  <a:schemeClr val="accent1"/>
                 </a:solidFill>
                 <a:latin typeface="Noto Sans"/>
                 <a:ea typeface="Noto Sans CJK JP"/>
@@ -15081,7 +15081,7 @@
             <a:r>
               <a:rPr sz="2200" b="1" lang="ja-JP" altLang="en-US">
                 <a:solidFill>
-                  <a:srgbClr val="2C9100"/>
+                  <a:schemeClr val="accent1"/>
                 </a:solidFill>
                 <a:latin typeface="Noto Sans"/>
                 <a:ea typeface="Noto Sans CJK JP"/>
@@ -15570,7 +15570,7 @@
             <a:r>
               <a:rPr sz="2200" b="1" lang="ja-JP" altLang="en-US">
                 <a:solidFill>
-                  <a:srgbClr val="2C9100"/>
+                  <a:schemeClr val="accent1"/>
                 </a:solidFill>
                 <a:latin typeface="Noto Sans"/>
                 <a:ea typeface="Noto Sans CJK JP"/>
@@ -16059,7 +16059,7 @@
             <a:r>
               <a:rPr sz="2200" b="1" lang="ja-JP" altLang="en-US">
                 <a:solidFill>
-                  <a:srgbClr val="2C9100"/>
+                  <a:schemeClr val="accent1"/>
                 </a:solidFill>
                 <a:latin typeface="Noto Sans"/>
                 <a:ea typeface="Noto Sans CJK JP"/>
@@ -16548,7 +16548,7 @@
             <a:r>
               <a:rPr sz="2200" b="1" lang="ja-JP" altLang="en-US">
                 <a:solidFill>
-                  <a:srgbClr val="2C9100"/>
+                  <a:schemeClr val="accent1"/>
                 </a:solidFill>
                 <a:latin typeface="Noto Sans"/>
                 <a:ea typeface="Noto Sans CJK JP"/>
@@ -17037,7 +17037,7 @@
             <a:r>
               <a:rPr sz="2200" b="1" lang="ja-JP" altLang="en-US">
                 <a:solidFill>
-                  <a:srgbClr val="2C9100"/>
+                  <a:schemeClr val="accent1"/>
                 </a:solidFill>
                 <a:latin typeface="Noto Sans"/>
                 <a:ea typeface="Noto Sans CJK JP"/>
@@ -17526,7 +17526,7 @@
             <a:r>
               <a:rPr sz="2200" b="1" lang="ja-JP" altLang="en-US">
                 <a:solidFill>
-                  <a:srgbClr val="2C9100"/>
+                  <a:schemeClr val="accent1"/>
                 </a:solidFill>
                 <a:latin typeface="Noto Sans"/>
                 <a:ea typeface="Noto Sans CJK JP"/>
@@ -18015,7 +18015,7 @@
             <a:r>
               <a:rPr sz="2200" b="1" lang="ja-JP" altLang="en-US">
                 <a:solidFill>
-                  <a:srgbClr val="2C9100"/>
+                  <a:schemeClr val="accent1"/>
                 </a:solidFill>
                 <a:latin typeface="Noto Sans"/>
                 <a:ea typeface="Noto Sans CJK JP"/>
@@ -22733,7 +22733,7 @@
             <a:r>
               <a:rPr sz="2200" b="1" lang="ja-JP" altLang="en-US">
                 <a:solidFill>
-                  <a:srgbClr val="2C9100"/>
+                  <a:schemeClr val="accent1"/>
                 </a:solidFill>
                 <a:latin typeface="Noto Sans"/>
                 <a:ea typeface="Noto Sans CJK JP"/>
@@ -23222,7 +23222,7 @@
             <a:r>
               <a:rPr sz="2200" b="1" lang="ja-JP" altLang="en-US">
                 <a:solidFill>
-                  <a:srgbClr val="2C9100"/>
+                  <a:schemeClr val="accent1"/>
                 </a:solidFill>
                 <a:latin typeface="Noto Sans"/>
                 <a:ea typeface="Noto Sans CJK JP"/>
@@ -23711,7 +23711,7 @@
             <a:r>
               <a:rPr sz="2200" b="1" lang="ja-JP" altLang="en-US">
                 <a:solidFill>
-                  <a:srgbClr val="2C9100"/>
+                  <a:schemeClr val="accent1"/>
                 </a:solidFill>
                 <a:latin typeface="Noto Sans"/>
                 <a:ea typeface="Noto Sans CJK JP"/>

</xml_diff>